<commit_message>
Embed the worked example's data as workbooks, not raw packages
The two CSV files were written into the pptx as OLE package objects, which
looked right from the outside -- the bytes were demonstrably inside the file --
but clicking either icon opened nothing. An OLE package must be wrapped in a
compound document; PowerPoint handed raw text under that prog id renders an
icon it cannot activate.

They are now embedded as real .xlsx workbooks under Excel.Sheet.12, which is
the same structure PowerPoint writes natively, so a double-click opens Excel.

tools/deck/xlsx.py writes a minimal valid workbook from a CSV using nothing but
zipfile and the five required XML parts. No new dependency, for the same reason
every other asset in this deck is vendored.

Co-Authored-By: Claude Opus 5 (1M context) <noreply@anthropic.com>
Claude-Session: https://claude.ai/code/session_013yYNhxSutyoQ7w7z92HSN2
</commit_message>
<xml_diff>
--- a/docs/MAYA-Model-and-Feature-Engineering.pptx
+++ b/docs/MAYA-Model-and-Feature-Engineering.pptx
@@ -31683,7 +31683,7 @@
                 </a:solidFill>
                 <a:latin typeface="Calibri"/>
               </a:rPr>
-              <a:t>Double-click either icon to open it. They are the files every number in this chapter was computed from, carrying their own provenance in the header — which series, from where, retrieved when, and which column means what.</a:t>
+              <a:t>Double-click either icon and it opens in Excel. They are the data every number in this chapter was computed from, carrying their own provenance in the header — which series, from where, retrieved when, and which column means what.</a:t>
             </a:r>
           </a:p>
           <a:p>
@@ -31840,12 +31840,12 @@
           <p:nvPr/>
         </p:nvGraphicFramePr>
         <p:xfrm>
-          <a:off x="6935248" y="1682496"/>
-          <a:ext cx="475488" cy="475488"/>
+          <a:off x="6916960" y="1645920"/>
+          <a:ext cx="566928" cy="566928"/>
         </p:xfrm>
         <a:graphic>
           <a:graphicData uri="http://schemas.openxmlformats.org/presentationml/2006/ole">
-            <p:oleObj showAsIcon="1" r:id="rId2" imgW="475488" imgH="475488" progId="Package">
+            <p:oleObj showAsIcon="1" r:id="rId2" imgW="965200" imgH="609600" progId="Excel.Sheet.12">
               <p:embed/>
               <p:pic>
                 <p:nvPicPr>
@@ -31861,8 +31861,8 @@
                 </p:blipFill>
                 <p:spPr>
                   <a:xfrm>
-                    <a:off x="6935248" y="1682496"/>
-                    <a:ext cx="475488" cy="475488"/>
+                    <a:off x="6916960" y="1645920"/>
+                    <a:ext cx="566928" cy="566928"/>
                   </a:xfrm>
                   <a:prstGeom prst="rect">
                     <a:avLst/>
@@ -31881,8 +31881,8 @@
         </p:nvSpPr>
         <p:spPr>
           <a:xfrm>
-            <a:off x="7575328" y="1627632"/>
-            <a:ext cx="3637958" cy="822960"/>
+            <a:off x="7611904" y="1609344"/>
+            <a:ext cx="3601382" cy="859536"/>
           </a:xfrm>
           <a:prstGeom prst="rect">
             <a:avLst/>
@@ -31951,7 +31951,7 @@
                 </a:solidFill>
                 <a:latin typeface="Calibri"/>
               </a:rPr>
-              <a:t>sp500_daily.csv</a:t>
+              <a:t>sp500_daily.xlsx</a:t>
             </a:r>
           </a:p>
         </p:txBody>
@@ -32055,12 +32055,12 @@
           <p:nvPr/>
         </p:nvGraphicFramePr>
         <p:xfrm>
-          <a:off x="6935248" y="3072384"/>
-          <a:ext cx="475488" cy="475488"/>
+          <a:off x="6916960" y="3035808"/>
+          <a:ext cx="566928" cy="566928"/>
         </p:xfrm>
         <a:graphic>
           <a:graphicData uri="http://schemas.openxmlformats.org/presentationml/2006/ole">
-            <p:oleObj showAsIcon="1" r:id="rId4" imgW="475488" imgH="475488" progId="Package">
+            <p:oleObj showAsIcon="1" r:id="rId4" imgW="965200" imgH="609600" progId="Excel.Sheet.12">
               <p:embed/>
               <p:pic>
                 <p:nvPicPr>
@@ -32076,8 +32076,8 @@
                 </p:blipFill>
                 <p:spPr>
                   <a:xfrm>
-                    <a:off x="6935248" y="3072384"/>
-                    <a:ext cx="475488" cy="475488"/>
+                    <a:off x="6916960" y="3035808"/>
+                    <a:ext cx="566928" cy="566928"/>
                   </a:xfrm>
                   <a:prstGeom prst="rect">
                     <a:avLst/>
@@ -32096,8 +32096,8 @@
         </p:nvSpPr>
         <p:spPr>
           <a:xfrm>
-            <a:off x="7575328" y="3017520"/>
-            <a:ext cx="3637958" cy="822960"/>
+            <a:off x="7611904" y="2999232"/>
+            <a:ext cx="3601382" cy="859536"/>
           </a:xfrm>
           <a:prstGeom prst="rect">
             <a:avLst/>
@@ -32166,7 +32166,7 @@
                 </a:solidFill>
                 <a:latin typeface="Calibri"/>
               </a:rPr>
-              <a:t>us_unemployment_monthly.csv</a:t>
+              <a:t>us_unemployment_monthly.xlsx</a:t>
             </a:r>
           </a:p>
         </p:txBody>
@@ -32299,7 +32299,7 @@
                 </a:solidFill>
                 <a:latin typeface="Calibri"/>
               </a:rPr>
-              <a:t>They also ship in the repository, at docs/data/. </a:t>
+              <a:t>They also ship in the repository, at docs/data/, as CSV. </a:t>
             </a:r>
             <a:r>
               <a:rPr sz="1050" b="0" i="0">

</xml_diff>